<commit_message>
Commit half-written unchecked exceptions as well as some notes in exceptions.md
</commit_message>
<xml_diff>
--- a/exceptions.pptx
+++ b/exceptions.pptx
@@ -116,7 +116,7 @@
 <file path=ppt/revisionInfo.xml><?xml version="1.0" encoding="utf-8"?>
 <p1510:revInfo xmlns:a="http://schemas.openxmlformats.org/drawingml/2006/main" xmlns:r="http://schemas.openxmlformats.org/officeDocument/2006/relationships" xmlns:p1510="http://schemas.microsoft.com/office/powerpoint/2015/10/main">
   <p1510:revLst>
-    <p1510:client id="{5BDA58EA-5045-4CF6-930E-F0DA9C9D737E}" v="23" dt="2026-04-21T07:06:40.334"/>
+    <p1510:client id="{5BDA58EA-5045-4CF6-930E-F0DA9C9D737E}" v="24" dt="2026-04-21T11:31:07.683"/>
   </p1510:revLst>
 </p1510:revInfo>
 </file>
@@ -126,7 +126,7 @@
   <pc:docChgLst>
     <pc:chgData name="Sanders Wang" userId="089d73b8-785c-4012-b931-81c632b6c9c7" providerId="ADAL" clId="{7A7E55CB-BBA3-4E2F-B01E-E4D114CCE9BA}"/>
     <pc:docChg chg="undo custSel addSld modSld">
-      <pc:chgData name="Sanders Wang" userId="089d73b8-785c-4012-b931-81c632b6c9c7" providerId="ADAL" clId="{7A7E55CB-BBA3-4E2F-B01E-E4D114CCE9BA}" dt="2026-04-21T07:06:48.600" v="203" actId="14100"/>
+      <pc:chgData name="Sanders Wang" userId="089d73b8-785c-4012-b931-81c632b6c9c7" providerId="ADAL" clId="{7A7E55CB-BBA3-4E2F-B01E-E4D114CCE9BA}" dt="2026-04-21T11:31:17.556" v="206" actId="11529"/>
       <pc:docMkLst>
         <pc:docMk/>
       </pc:docMkLst>
@@ -426,7 +426,7 @@
         </pc:cxnChg>
       </pc:sldChg>
       <pc:sldChg chg="addSp delSp modSp add mod">
-        <pc:chgData name="Sanders Wang" userId="089d73b8-785c-4012-b931-81c632b6c9c7" providerId="ADAL" clId="{7A7E55CB-BBA3-4E2F-B01E-E4D114CCE9BA}" dt="2026-04-21T07:06:48.600" v="203" actId="14100"/>
+        <pc:chgData name="Sanders Wang" userId="089d73b8-785c-4012-b931-81c632b6c9c7" providerId="ADAL" clId="{7A7E55CB-BBA3-4E2F-B01E-E4D114CCE9BA}" dt="2026-04-21T11:31:17.556" v="206" actId="11529"/>
         <pc:sldMkLst>
           <pc:docMk/>
           <pc:sldMk cId="1446090393" sldId="257"/>
@@ -575,6 +575,14 @@
             <ac:spMk id="24" creationId="{B0A7D354-C5AF-3BD6-E834-AD47E33B4D7B}"/>
           </ac:spMkLst>
         </pc:spChg>
+        <pc:spChg chg="add mod">
+          <ac:chgData name="Sanders Wang" userId="089d73b8-785c-4012-b931-81c632b6c9c7" providerId="ADAL" clId="{7A7E55CB-BBA3-4E2F-B01E-E4D114CCE9BA}" dt="2026-04-21T11:31:11.575" v="205" actId="1076"/>
+          <ac:spMkLst>
+            <pc:docMk/>
+            <pc:sldMk cId="1446090393" sldId="257"/>
+            <ac:spMk id="37" creationId="{AD269C09-C1E5-CA13-F95E-BBFBD82A95A6}"/>
+          </ac:spMkLst>
+        </pc:spChg>
         <pc:cxnChg chg="del mod">
           <ac:chgData name="Sanders Wang" userId="089d73b8-785c-4012-b931-81c632b6c9c7" providerId="ADAL" clId="{7A7E55CB-BBA3-4E2F-B01E-E4D114CCE9BA}" dt="2026-04-21T06:22:34.366" v="56" actId="478"/>
           <ac:cxnSpMkLst>
@@ -645,6 +653,14 @@
             <pc:docMk/>
             <pc:sldMk cId="1446090393" sldId="257"/>
             <ac:cxnSpMk id="33" creationId="{522B9440-BCFD-37D4-8537-2FC7BE7DB66E}"/>
+          </ac:cxnSpMkLst>
+        </pc:cxnChg>
+        <pc:cxnChg chg="add">
+          <ac:chgData name="Sanders Wang" userId="089d73b8-785c-4012-b931-81c632b6c9c7" providerId="ADAL" clId="{7A7E55CB-BBA3-4E2F-B01E-E4D114CCE9BA}" dt="2026-04-21T11:31:17.556" v="206" actId="11529"/>
+          <ac:cxnSpMkLst>
+            <pc:docMk/>
+            <pc:sldMk cId="1446090393" sldId="257"/>
+            <ac:cxnSpMk id="39" creationId="{CAB2DB1B-1881-B059-E523-CD3599A54248}"/>
           </ac:cxnSpMkLst>
         </pc:cxnChg>
       </pc:sldChg>
@@ -6516,6 +6532,102 @@
               </a:schemeClr>
             </a:solidFill>
             <a:prstDash val="dash"/>
+            <a:tailEnd type="triangle"/>
+          </a:ln>
+        </p:spPr>
+        <p:style>
+          <a:lnRef idx="2">
+            <a:schemeClr val="accent1"/>
+          </a:lnRef>
+          <a:fillRef idx="0">
+            <a:schemeClr val="accent1"/>
+          </a:fillRef>
+          <a:effectRef idx="1">
+            <a:schemeClr val="accent1"/>
+          </a:effectRef>
+          <a:fontRef idx="minor">
+            <a:schemeClr val="tx1"/>
+          </a:fontRef>
+        </p:style>
+      </p:cxnSp>
+      <p:sp>
+        <p:nvSpPr>
+          <p:cNvPr id="37" name="Rectangle 36">
+            <a:extLst>
+              <a:ext uri="{FF2B5EF4-FFF2-40B4-BE49-F238E27FC236}">
+                <a16:creationId xmlns:a16="http://schemas.microsoft.com/office/drawing/2014/main" id="{AD269C09-C1E5-CA13-F95E-BBFBD82A95A6}"/>
+              </a:ext>
+            </a:extLst>
+          </p:cNvPr>
+          <p:cNvSpPr/>
+          <p:nvPr/>
+        </p:nvSpPr>
+        <p:spPr>
+          <a:xfrm>
+            <a:off x="9388929" y="2577193"/>
+            <a:ext cx="2296886" cy="653142"/>
+          </a:xfrm>
+          <a:prstGeom prst="rect">
+            <a:avLst/>
+          </a:prstGeom>
+          <a:noFill/>
+        </p:spPr>
+        <p:style>
+          <a:lnRef idx="2">
+            <a:schemeClr val="accent1">
+              <a:shade val="15000"/>
+            </a:schemeClr>
+          </a:lnRef>
+          <a:fillRef idx="1">
+            <a:schemeClr val="accent1"/>
+          </a:fillRef>
+          <a:effectRef idx="0">
+            <a:schemeClr val="accent1"/>
+          </a:effectRef>
+          <a:fontRef idx="minor">
+            <a:schemeClr val="lt1"/>
+          </a:fontRef>
+        </p:style>
+        <p:txBody>
+          <a:bodyPr rtlCol="0" anchor="ctr"/>
+          <a:lstStyle/>
+          <a:p>
+            <a:pPr algn="ctr"/>
+            <a:r>
+              <a:rPr lang="en-US" dirty="0">
+                <a:solidFill>
+                  <a:schemeClr val="tx1"/>
+                </a:solidFill>
+              </a:rPr>
+              <a:t>Exception</a:t>
+            </a:r>
+          </a:p>
+        </p:txBody>
+      </p:sp>
+      <p:cxnSp>
+        <p:nvCxnSpPr>
+          <p:cNvPr id="39" name="Straight Arrow Connector 38">
+            <a:extLst>
+              <a:ext uri="{FF2B5EF4-FFF2-40B4-BE49-F238E27FC236}">
+                <a16:creationId xmlns:a16="http://schemas.microsoft.com/office/drawing/2014/main" id="{CAB2DB1B-1881-B059-E523-CD3599A54248}"/>
+              </a:ext>
+            </a:extLst>
+          </p:cNvPr>
+          <p:cNvCxnSpPr>
+            <a:stCxn id="11" idx="2"/>
+            <a:endCxn id="37" idx="0"/>
+          </p:cNvCxnSpPr>
+          <p:nvPr/>
+        </p:nvCxnSpPr>
+        <p:spPr>
+          <a:xfrm>
+            <a:off x="10537372" y="2309131"/>
+            <a:ext cx="0" cy="268062"/>
+          </a:xfrm>
+          <a:prstGeom prst="straightConnector1">
+            <a:avLst/>
+          </a:prstGeom>
+          <a:ln>
             <a:tailEnd type="triangle"/>
           </a:ln>
         </p:spPr>

</xml_diff>